<commit_message>
Add SOC web console (src/webapp.py, Flask) + architecture diagram + flask dependency
</commit_message>
<xml_diff>
--- a/docs/SentinelAI_Presentation.pptx
+++ b/docs/SentinelAI_Presentation.pptx
@@ -4161,7 +4161,7 @@
               </a:defRPr>
             </a:pPr>
             <a:r>
-              <a:t>• LSTM sequence model: F1 94.0% - word ORDER adds signal</a:t>
+              <a:t>• LSTM sequence model: F1 94.4% - word ORDER adds signal</a:t>
             </a:r>
           </a:p>
           <a:p>
@@ -5098,7 +5098,7 @@
               </a:defRPr>
             </a:pPr>
             <a:r>
-              <a:t>• NLP: LSTM F1 94.0% beats TF-IDF 91.8% (real data)</a:t>
+              <a:t>• NLP: LSTM F1 94.4% beats TF-IDF 91.8% (real data)</a:t>
             </a:r>
           </a:p>
           <a:p>

</xml_diff>

<commit_message>
Complete AI pipeline on 100% real data
- Data: real CICIDS2017 flows (32,466 x 16 features x 5 classes), real
  Malimg byte-plots (4 families, 771 images), real UCI SMS (5,572), live
  malware-domain feed (18,146). Documented synthetic offline fallback.
- Replace pixel-duplicated Autorun.K/Yuner.A (figshare mirror) with
  Lolyda.AA2 + Alueron.gen!J; per-class sampling caps.
- Preprocessing: inf->NaN (real rate artefact), median imputation, one-hot,
  log1p, StandardScaler train-only, SelectKBest, stratified 80/20.
- Supervised: 6 classifiers, RF 99.63% / 0.996 macro-F1, 5-fold CV,
  GridSearch, class_weight experiment, FP/FN analysis.
- Unsupervised: K-Means, DBSCAN, Ward+dendrogram, PCA, Isolation Forest.
- DL MLP 97.5%; NLP LSTM F1 0.944 vs TF-IDF 0.918; CV CNN 100% vs HOG+SVM.
- RL from-scratch Q-Learning (+2.44 vs -3.67); Agent 27 events 100% flows.
- Web console recalibrated to real CICIDS2017 medians; 21/21 tests pass.
- Docs: 13-section DOCX report, PPTX, Arabic explainers.
</commit_message>
<xml_diff>
--- a/docs/SentinelAI_Presentation.pptx
+++ b/docs/SentinelAI_Presentation.pptx
@@ -728,7 +728,7 @@
           <a:lstStyle/>
           <a:p>
             <a:r>
-              <a:t>Defensible source story: 2 real sources + documented generated data + live feed download.</a:t>
+              <a:t>Defensible source story: 4 real sources (captured traffic, real malware corpus, public SMS data, live feed) + documented offline fallback.</a:t>
             </a:r>
           </a:p>
         </p:txBody>
@@ -3991,7 +3991,7 @@
           </a:p>
           <a:p>
             <a:r>
-              <a:t>Supervisor: Eng. Sondos Saif</a:t>
+              <a:t>Supervisor: Eng. Sondos Saif  |  Date: 10 September 2026</a:t>
             </a:r>
           </a:p>
         </p:txBody>
@@ -4346,7 +4346,7 @@
               </a:defRPr>
             </a:pPr>
             <a:r>
-              <a:t>• Test accuracy 100.0% on 144 unseen images</a:t>
+              <a:t>• Test accuracy 100.0% on 155 unseen images</a:t>
             </a:r>
           </a:p>
           <a:p>
@@ -4376,7 +4376,7 @@
               </a:defRPr>
             </a:pPr>
             <a:r>
-              <a:t>• Noise/brightness/occlusion injected -&gt; model must generalize</a:t>
+              <a:t>• REAL Malimg byte-plots (native sizes 256x264 - 768x683, resized on load)</a:t>
             </a:r>
           </a:p>
         </p:txBody>
@@ -4561,7 +4561,7 @@
               </a:defRPr>
             </a:pPr>
             <a:r>
-              <a:t>• Learned policy avg reward 2.33 vs AlwaysBlock 1.00, AlwaysMonitor -3.67</a:t>
+              <a:t>• Learned policy avg reward 2.44 vs AlwaysBlock 1.00, AlwaysMonitor -3.67</a:t>
             </a:r>
           </a:p>
           <a:p>
@@ -4782,7 +4782,7 @@
               </a:defRPr>
             </a:pPr>
             <a:r>
-              <a:t>• Demo: 27 events -&gt; {'Monitor': 14, 'Isolate_Host': 7, 'Alert_Analyst': 4, 'Block_IP': 2}</a:t>
+              <a:t>• Demo: 27 events -&gt; {'Isolate_Host': 11, 'Monitor': 7, 'Alert_Analyst': 6, 'Block_IP': 3}</a:t>
             </a:r>
           </a:p>
         </p:txBody>
@@ -5068,22 +5068,22 @@
               </a:defRPr>
             </a:pPr>
             <a:r>
-              <a:t>• Supervised (RandomForest): 99.8% accuracy / 99.7% macro-F1 (5-fold CV validated)</a:t>
-            </a:r>
-          </a:p>
-          <a:p>
-            <a:pPr>
-              <a:spcAft>
-                <a:spcPts val="800"/>
-              </a:spcAft>
-              <a:defRPr sz="1600">
-                <a:solidFill>
-                  <a:srgbClr val="404040"/>
-                </a:solidFill>
-              </a:defRPr>
-            </a:pPr>
-            <a:r>
-              <a:t>• MLP: 98.5% (compared honestly)</a:t>
+              <a:t>• Supervised (RandomForest): 99.6% accuracy / 99.6% macro-F1 (5-fold CV validated)</a:t>
+            </a:r>
+          </a:p>
+          <a:p>
+            <a:pPr>
+              <a:spcAft>
+                <a:spcPts val="800"/>
+              </a:spcAft>
+              <a:defRPr sz="1600">
+                <a:solidFill>
+                  <a:srgbClr val="404040"/>
+                </a:solidFill>
+              </a:defRPr>
+            </a:pPr>
+            <a:r>
+              <a:t>• MLP: 97.5% (compared honestly)</a:t>
             </a:r>
           </a:p>
           <a:p>
@@ -5128,37 +5128,37 @@
               </a:defRPr>
             </a:pPr>
             <a:r>
-              <a:t>• Isolation Forest: precision 94.8%</a:t>
-            </a:r>
-          </a:p>
-          <a:p>
-            <a:pPr>
-              <a:spcAft>
-                <a:spcPts val="800"/>
-              </a:spcAft>
-              <a:defRPr sz="1600">
-                <a:solidFill>
-                  <a:srgbClr val="404040"/>
-                </a:solidFill>
-              </a:defRPr>
-            </a:pPr>
-            <a:r>
-              <a:t>• RL policy beats all baselines (2.33 avg reward)</a:t>
-            </a:r>
-          </a:p>
-          <a:p>
-            <a:pPr>
-              <a:spcAft>
-                <a:spcPts val="800"/>
-              </a:spcAft>
-              <a:defRPr sz="1600">
-                <a:solidFill>
-                  <a:srgbClr val="404040"/>
-                </a:solidFill>
-              </a:defRPr>
-            </a:pPr>
-            <a:r>
-              <a:t>• 15/15 automated tests pass; full reproducible pipeline</a:t>
+              <a:t>• Isolation Forest: precision 88.3%</a:t>
+            </a:r>
+          </a:p>
+          <a:p>
+            <a:pPr>
+              <a:spcAft>
+                <a:spcPts val="800"/>
+              </a:spcAft>
+              <a:defRPr sz="1600">
+                <a:solidFill>
+                  <a:srgbClr val="404040"/>
+                </a:solidFill>
+              </a:defRPr>
+            </a:pPr>
+            <a:r>
+              <a:t>• RL policy beats all baselines (2.44 avg reward)</a:t>
+            </a:r>
+          </a:p>
+          <a:p>
+            <a:pPr>
+              <a:spcAft>
+                <a:spcPts val="800"/>
+              </a:spcAft>
+              <a:defRPr sz="1600">
+                <a:solidFill>
+                  <a:srgbClr val="404040"/>
+                </a:solidFill>
+              </a:defRPr>
+            </a:pPr>
+            <a:r>
+              <a:t>• 21/21 automated tests pass; full reproducible pipeline</a:t>
             </a:r>
           </a:p>
         </p:txBody>
@@ -5259,7 +5259,7 @@
               </a:defRPr>
             </a:pPr>
             <a:r>
-              <a:t>• Real captured traffic (CICIDS2017) + real Malimg corpus</a:t>
+              <a:t>• Scale to the full CICIDS2017 corpus (2.8M flows) and all 25 Malimg families</a:t>
             </a:r>
           </a:p>
           <a:p>
@@ -5772,7 +5772,7 @@
               </a:defRPr>
             </a:pPr>
             <a:r>
-              <a:t>• Supervised: 6 classifiers on 25k network flows</a:t>
+              <a:t>• Supervised: 6 classifiers on 32,445 real network flows</a:t>
             </a:r>
           </a:p>
           <a:p>
@@ -5908,7 +5908,7 @@
               </a:defRPr>
             </a:pPr>
             <a:r>
-              <a:t>Data Collection (Stage 2)</a:t>
+              <a:t>Data Collection (Stage 2) - REAL datasets</a:t>
             </a:r>
           </a:p>
         </p:txBody>
@@ -5987,37 +5987,22 @@
               </a:defRPr>
             </a:pPr>
             <a:r>
-              <a:t>• Network flows: 25,200 rows, 16 features, 5 classes (imbalanced)</a:t>
-            </a:r>
-          </a:p>
-          <a:p>
-            <a:pPr>
-              <a:spcAft>
-                <a:spcPts val="800"/>
-              </a:spcAft>
-              <a:defRPr sz="1600">
-                <a:solidFill>
-                  <a:srgbClr val="404040"/>
-                </a:solidFill>
-              </a:defRPr>
-            </a:pPr>
-            <a:r>
-              <a:t>• Generated with documented per-class statistical models (seeded, reproducible)</a:t>
-            </a:r>
-          </a:p>
-          <a:p>
-            <a:pPr>
-              <a:spcAft>
-                <a:spcPts val="800"/>
-              </a:spcAft>
-              <a:defRPr sz="1600">
-                <a:solidFill>
-                  <a:srgbClr val="404040"/>
-                </a:solidFill>
-              </a:defRPr>
-            </a:pPr>
-            <a:r>
-              <a:t>• Imperfections injected on purpose: duplicates, missing values, impossible values</a:t>
+              <a:t>• Network flows: 32,466 REAL CICIDS2017 captured flows, mapped to 16 features, 5 classes (imbalanced)</a:t>
+            </a:r>
+          </a:p>
+          <a:p>
+            <a:pPr>
+              <a:spcAft>
+                <a:spcPts val="800"/>
+              </a:spcAft>
+              <a:defRPr sz="1600">
+                <a:solidFill>
+                  <a:srgbClr val="404040"/>
+                </a:solidFill>
+              </a:defRPr>
+            </a:pPr>
+            <a:r>
+              <a:t>• Malware images: REAL Malimg corpus - Allaple.A, C2LOP.P, Lolyda.AA2, Alueron.gen!J resized to 48x48</a:t>
             </a:r>
           </a:p>
           <a:p>
@@ -6047,22 +6032,22 @@
               </a:defRPr>
             </a:pPr>
             <a:r>
-              <a:t>• Malware images: 720 byte-plots, 4 families (Nataraj 2011 style)</a:t>
-            </a:r>
-          </a:p>
-          <a:p>
-            <a:pPr>
-              <a:spcAft>
-                <a:spcPts val="800"/>
-              </a:spcAft>
-              <a:defRPr sz="1600">
-                <a:solidFill>
-                  <a:srgbClr val="404040"/>
-                </a:solidFill>
-              </a:defRPr>
-            </a:pPr>
-            <a:r>
               <a:t>• Threat-intel feed: REAL - 18k+ malware domains downloaded over HTTPS (web/network programming)</a:t>
+            </a:r>
+          </a:p>
+          <a:p>
+            <a:pPr>
+              <a:spcAft>
+                <a:spcPts val="800"/>
+              </a:spcAft>
+              <a:defRPr sz="1600">
+                <a:solidFill>
+                  <a:srgbClr val="404040"/>
+                </a:solidFill>
+              </a:defRPr>
+            </a:pPr>
+            <a:r>
+              <a:t>• Offline fallback: documented synthetic generators</a:t>
             </a:r>
           </a:p>
         </p:txBody>
@@ -6187,7 +6172,7 @@
               </a:defRPr>
             </a:pPr>
             <a:r>
-              <a:t>• Removed 178 duplicates (bias removal)</a:t>
+              <a:t>• Removed 21 duplicates (bias removal)</a:t>
             </a:r>
           </a:p>
           <a:p>
@@ -6262,7 +6247,7 @@
               </a:defRPr>
             </a:pPr>
             <a:r>
-              <a:t>• SelectKBest kept 12 / 17 features</a:t>
+              <a:t>• SelectKBest kept 12 / 16 features</a:t>
             </a:r>
           </a:p>
           <a:p>
@@ -6402,7 +6387,7 @@
               </a:defRPr>
             </a:pPr>
             <a:r>
-              <a:t>• Best: RandomForest - accuracy 99.8%, macro-F1 99.7%</a:t>
+              <a:t>• Best: RandomForest - accuracy 99.6%, macro-F1 99.6%</a:t>
             </a:r>
           </a:p>
           <a:p>
@@ -6462,22 +6447,22 @@
               </a:defRPr>
             </a:pPr>
             <a:r>
-              <a:t>• 5-fold CV validates stability (99.7% ± 0.0007)</a:t>
-            </a:r>
-          </a:p>
-          <a:p>
-            <a:pPr>
-              <a:spcAft>
-                <a:spcPts val="800"/>
-              </a:spcAft>
-              <a:defRPr sz="1600">
-                <a:solidFill>
-                  <a:srgbClr val="404040"/>
-                </a:solidFill>
-              </a:defRPr>
-            </a:pPr>
-            <a:r>
-              <a:t>• GridSearchCV tuning: {'max_depth': 22, 'n_estimators': 200}</a:t>
+              <a:t>• 5-fold CV validates stability (99.7% ± 0.0004)</a:t>
+            </a:r>
+          </a:p>
+          <a:p>
+            <a:pPr>
+              <a:spcAft>
+                <a:spcPts val="800"/>
+              </a:spcAft>
+              <a:defRPr sz="1600">
+                <a:solidFill>
+                  <a:srgbClr val="404040"/>
+                </a:solidFill>
+              </a:defRPr>
+            </a:pPr>
+            <a:r>
+              <a:t>• GridSearchCV tuning: {'max_depth': None, 'n_estimators': 400}</a:t>
             </a:r>
           </a:p>
         </p:txBody>
@@ -6802,37 +6787,37 @@
               </a:defRPr>
             </a:pPr>
             <a:r>
-              <a:t>• K-Means: k=4 chosen by silhouette; purity 76.7%, ARI 0.46 WITHOUT labels</a:t>
-            </a:r>
-          </a:p>
-          <a:p>
-            <a:pPr>
-              <a:spcAft>
-                <a:spcPts val="800"/>
-              </a:spcAft>
-              <a:defRPr sz="1600">
-                <a:solidFill>
-                  <a:srgbClr val="404040"/>
-                </a:solidFill>
-              </a:defRPr>
-            </a:pPr>
-            <a:r>
-              <a:t>• Hierarchical (Ward): dendrogram confirms the same structure (ARI 0.47)</a:t>
-            </a:r>
-          </a:p>
-          <a:p>
-            <a:pPr>
-              <a:spcAft>
-                <a:spcPts val="800"/>
-              </a:spcAft>
-              <a:defRPr sz="1600">
-                <a:solidFill>
-                  <a:srgbClr val="404040"/>
-                </a:solidFill>
-              </a:defRPr>
-            </a:pPr>
-            <a:r>
-              <a:t>• DBSCAN: 2 clusters + 0.0% noise on PCA subspace</a:t>
+              <a:t>• K-Means: k=2 chosen by silhouette; purity 46.3%, ARI 0.07 WITHOUT labels</a:t>
+            </a:r>
+          </a:p>
+          <a:p>
+            <a:pPr>
+              <a:spcAft>
+                <a:spcPts val="800"/>
+              </a:spcAft>
+              <a:defRPr sz="1600">
+                <a:solidFill>
+                  <a:srgbClr val="404040"/>
+                </a:solidFill>
+              </a:defRPr>
+            </a:pPr>
+            <a:r>
+              <a:t>• Hierarchical (Ward): dendrogram confirms the same structure (ARI 0.09)</a:t>
+            </a:r>
+          </a:p>
+          <a:p>
+            <a:pPr>
+              <a:spcAft>
+                <a:spcPts val="800"/>
+              </a:spcAft>
+              <a:defRPr sz="1600">
+                <a:solidFill>
+                  <a:srgbClr val="404040"/>
+                </a:solidFill>
+              </a:defRPr>
+            </a:pPr>
+            <a:r>
+              <a:t>• DBSCAN: 1 clusters + 0.4% noise on PCA subspace</a:t>
             </a:r>
           </a:p>
           <a:p>
@@ -6862,7 +6847,7 @@
               </a:defRPr>
             </a:pPr>
             <a:r>
-              <a:t>• Anomaly detection: precision 94.8%, recall 61.4%</a:t>
+              <a:t>• Anomaly detection: precision 88.3%, recall 24.1%</a:t>
             </a:r>
           </a:p>
           <a:p>
@@ -7017,22 +7002,22 @@
               </a:defRPr>
             </a:pPr>
             <a:r>
-              <a:t>• Accuracy 98.5%, macro-F1 98.2%</a:t>
-            </a:r>
-          </a:p>
-          <a:p>
-            <a:pPr>
-              <a:spcAft>
-                <a:spcPts val="800"/>
-              </a:spcAft>
-              <a:defRPr sz="1600">
-                <a:solidFill>
-                  <a:srgbClr val="404040"/>
-                </a:solidFill>
-              </a:defRPr>
-            </a:pPr>
-            <a:r>
-              <a:t>• vs RandomForest 99.7% - ensembles win on small tabular data</a:t>
+              <a:t>• Accuracy 97.5%, macro-F1 98.0%</a:t>
+            </a:r>
+          </a:p>
+          <a:p>
+            <a:pPr>
+              <a:spcAft>
+                <a:spcPts val="800"/>
+              </a:spcAft>
+              <a:defRPr sz="1600">
+                <a:solidFill>
+                  <a:srgbClr val="404040"/>
+                </a:solidFill>
+              </a:defRPr>
+            </a:pPr>
+            <a:r>
+              <a:t>• vs RandomForest 99.6% - ensembles win on small tabular data</a:t>
             </a:r>
           </a:p>
           <a:p>

</xml_diff>